<commit_message>
Class ReservationLayoutHtml replace by ReservationLayoutHtmlFiles
</commit_message>
<xml_diff>
--- a/Description/ReservationLayout.pptx
+++ b/Description/ReservationLayout.pptx
@@ -288,7 +288,7 @@
           <a:p>
             <a:fld id="{DDCE6D58-9B57-4731-A47B-3CD41B48F0A9}" type="datetimeFigureOut">
               <a:rPr lang="de-CH" smtClean="0"/>
-              <a:t>15.05.2026</a:t>
+              <a:t>16.05.2026</a:t>
             </a:fld>
             <a:endParaRPr lang="de-CH"/>
           </a:p>
@@ -458,7 +458,7 @@
           <a:p>
             <a:fld id="{DDCE6D58-9B57-4731-A47B-3CD41B48F0A9}" type="datetimeFigureOut">
               <a:rPr lang="de-CH" smtClean="0"/>
-              <a:t>15.05.2026</a:t>
+              <a:t>16.05.2026</a:t>
             </a:fld>
             <a:endParaRPr lang="de-CH"/>
           </a:p>
@@ -638,7 +638,7 @@
           <a:p>
             <a:fld id="{DDCE6D58-9B57-4731-A47B-3CD41B48F0A9}" type="datetimeFigureOut">
               <a:rPr lang="de-CH" smtClean="0"/>
-              <a:t>15.05.2026</a:t>
+              <a:t>16.05.2026</a:t>
             </a:fld>
             <a:endParaRPr lang="de-CH"/>
           </a:p>
@@ -808,7 +808,7 @@
           <a:p>
             <a:fld id="{DDCE6D58-9B57-4731-A47B-3CD41B48F0A9}" type="datetimeFigureOut">
               <a:rPr lang="de-CH" smtClean="0"/>
-              <a:t>15.05.2026</a:t>
+              <a:t>16.05.2026</a:t>
             </a:fld>
             <a:endParaRPr lang="de-CH"/>
           </a:p>
@@ -1054,7 +1054,7 @@
           <a:p>
             <a:fld id="{DDCE6D58-9B57-4731-A47B-3CD41B48F0A9}" type="datetimeFigureOut">
               <a:rPr lang="de-CH" smtClean="0"/>
-              <a:t>15.05.2026</a:t>
+              <a:t>16.05.2026</a:t>
             </a:fld>
             <a:endParaRPr lang="de-CH"/>
           </a:p>
@@ -1286,7 +1286,7 @@
           <a:p>
             <a:fld id="{DDCE6D58-9B57-4731-A47B-3CD41B48F0A9}" type="datetimeFigureOut">
               <a:rPr lang="de-CH" smtClean="0"/>
-              <a:t>15.05.2026</a:t>
+              <a:t>16.05.2026</a:t>
             </a:fld>
             <a:endParaRPr lang="de-CH"/>
           </a:p>
@@ -1653,7 +1653,7 @@
           <a:p>
             <a:fld id="{DDCE6D58-9B57-4731-A47B-3CD41B48F0A9}" type="datetimeFigureOut">
               <a:rPr lang="de-CH" smtClean="0"/>
-              <a:t>15.05.2026</a:t>
+              <a:t>16.05.2026</a:t>
             </a:fld>
             <a:endParaRPr lang="de-CH"/>
           </a:p>
@@ -1771,7 +1771,7 @@
           <a:p>
             <a:fld id="{DDCE6D58-9B57-4731-A47B-3CD41B48F0A9}" type="datetimeFigureOut">
               <a:rPr lang="de-CH" smtClean="0"/>
-              <a:t>15.05.2026</a:t>
+              <a:t>16.05.2026</a:t>
             </a:fld>
             <a:endParaRPr lang="de-CH"/>
           </a:p>
@@ -1866,7 +1866,7 @@
           <a:p>
             <a:fld id="{DDCE6D58-9B57-4731-A47B-3CD41B48F0A9}" type="datetimeFigureOut">
               <a:rPr lang="de-CH" smtClean="0"/>
-              <a:t>15.05.2026</a:t>
+              <a:t>16.05.2026</a:t>
             </a:fld>
             <a:endParaRPr lang="de-CH"/>
           </a:p>
@@ -2143,7 +2143,7 @@
           <a:p>
             <a:fld id="{DDCE6D58-9B57-4731-A47B-3CD41B48F0A9}" type="datetimeFigureOut">
               <a:rPr lang="de-CH" smtClean="0"/>
-              <a:t>15.05.2026</a:t>
+              <a:t>16.05.2026</a:t>
             </a:fld>
             <a:endParaRPr lang="de-CH"/>
           </a:p>
@@ -2396,7 +2396,7 @@
           <a:p>
             <a:fld id="{DDCE6D58-9B57-4731-A47B-3CD41B48F0A9}" type="datetimeFigureOut">
               <a:rPr lang="de-CH" smtClean="0"/>
-              <a:t>15.05.2026</a:t>
+              <a:t>16.05.2026</a:t>
             </a:fld>
             <a:endParaRPr lang="de-CH"/>
           </a:p>
@@ -2609,7 +2609,7 @@
           <a:p>
             <a:fld id="{DDCE6D58-9B57-4731-A47B-3CD41B48F0A9}" type="datetimeFigureOut">
               <a:rPr lang="de-CH" smtClean="0"/>
-              <a:t>15.05.2026</a:t>
+              <a:t>16.05.2026</a:t>
             </a:fld>
             <a:endParaRPr lang="de-CH"/>
           </a:p>
@@ -18980,7 +18980,7 @@
                 <a:latin typeface="Arial" panose="020B0604020202020204" pitchFamily="34" charset="0"/>
                 <a:cs typeface="Arial" panose="020B0604020202020204" pitchFamily="34" charset="0"/>
               </a:rPr>
-              <a:t>ReservationLayoutHtml</a:t>
+              <a:t>LayoutHtmlFiles</a:t>
             </a:r>
             <a:endParaRPr lang="de-CH" dirty="0">
               <a:solidFill>
@@ -19501,7 +19501,7 @@
                 <a:latin typeface="Arial" panose="020B0604020202020204" pitchFamily="34" charset="0"/>
                 <a:cs typeface="Arial" panose="020B0604020202020204" pitchFamily="34" charset="0"/>
               </a:rPr>
-              <a:t>ReservationLayoutHtml.js</a:t>
+              <a:t>ReservationLayoutHtmlFiles.js</a:t>
             </a:r>
           </a:p>
         </p:txBody>

</xml_diff>

<commit_message>
Start getting data for layout model
</commit_message>
<xml_diff>
--- a/Description/ReservationLayout.pptx
+++ b/Description/ReservationLayout.pptx
@@ -288,7 +288,7 @@
           <a:p>
             <a:fld id="{DDCE6D58-9B57-4731-A47B-3CD41B48F0A9}" type="datetimeFigureOut">
               <a:rPr lang="de-CH" smtClean="0"/>
-              <a:t>16.05.2026</a:t>
+              <a:t>17.05.2026</a:t>
             </a:fld>
             <a:endParaRPr lang="de-CH"/>
           </a:p>
@@ -458,7 +458,7 @@
           <a:p>
             <a:fld id="{DDCE6D58-9B57-4731-A47B-3CD41B48F0A9}" type="datetimeFigureOut">
               <a:rPr lang="de-CH" smtClean="0"/>
-              <a:t>16.05.2026</a:t>
+              <a:t>17.05.2026</a:t>
             </a:fld>
             <a:endParaRPr lang="de-CH"/>
           </a:p>
@@ -638,7 +638,7 @@
           <a:p>
             <a:fld id="{DDCE6D58-9B57-4731-A47B-3CD41B48F0A9}" type="datetimeFigureOut">
               <a:rPr lang="de-CH" smtClean="0"/>
-              <a:t>16.05.2026</a:t>
+              <a:t>17.05.2026</a:t>
             </a:fld>
             <a:endParaRPr lang="de-CH"/>
           </a:p>
@@ -808,7 +808,7 @@
           <a:p>
             <a:fld id="{DDCE6D58-9B57-4731-A47B-3CD41B48F0A9}" type="datetimeFigureOut">
               <a:rPr lang="de-CH" smtClean="0"/>
-              <a:t>16.05.2026</a:t>
+              <a:t>17.05.2026</a:t>
             </a:fld>
             <a:endParaRPr lang="de-CH"/>
           </a:p>
@@ -1054,7 +1054,7 @@
           <a:p>
             <a:fld id="{DDCE6D58-9B57-4731-A47B-3CD41B48F0A9}" type="datetimeFigureOut">
               <a:rPr lang="de-CH" smtClean="0"/>
-              <a:t>16.05.2026</a:t>
+              <a:t>17.05.2026</a:t>
             </a:fld>
             <a:endParaRPr lang="de-CH"/>
           </a:p>
@@ -1286,7 +1286,7 @@
           <a:p>
             <a:fld id="{DDCE6D58-9B57-4731-A47B-3CD41B48F0A9}" type="datetimeFigureOut">
               <a:rPr lang="de-CH" smtClean="0"/>
-              <a:t>16.05.2026</a:t>
+              <a:t>17.05.2026</a:t>
             </a:fld>
             <a:endParaRPr lang="de-CH"/>
           </a:p>
@@ -1653,7 +1653,7 @@
           <a:p>
             <a:fld id="{DDCE6D58-9B57-4731-A47B-3CD41B48F0A9}" type="datetimeFigureOut">
               <a:rPr lang="de-CH" smtClean="0"/>
-              <a:t>16.05.2026</a:t>
+              <a:t>17.05.2026</a:t>
             </a:fld>
             <a:endParaRPr lang="de-CH"/>
           </a:p>
@@ -1771,7 +1771,7 @@
           <a:p>
             <a:fld id="{DDCE6D58-9B57-4731-A47B-3CD41B48F0A9}" type="datetimeFigureOut">
               <a:rPr lang="de-CH" smtClean="0"/>
-              <a:t>16.05.2026</a:t>
+              <a:t>17.05.2026</a:t>
             </a:fld>
             <a:endParaRPr lang="de-CH"/>
           </a:p>
@@ -1866,7 +1866,7 @@
           <a:p>
             <a:fld id="{DDCE6D58-9B57-4731-A47B-3CD41B48F0A9}" type="datetimeFigureOut">
               <a:rPr lang="de-CH" smtClean="0"/>
-              <a:t>16.05.2026</a:t>
+              <a:t>17.05.2026</a:t>
             </a:fld>
             <a:endParaRPr lang="de-CH"/>
           </a:p>
@@ -2143,7 +2143,7 @@
           <a:p>
             <a:fld id="{DDCE6D58-9B57-4731-A47B-3CD41B48F0A9}" type="datetimeFigureOut">
               <a:rPr lang="de-CH" smtClean="0"/>
-              <a:t>16.05.2026</a:t>
+              <a:t>17.05.2026</a:t>
             </a:fld>
             <a:endParaRPr lang="de-CH"/>
           </a:p>
@@ -2396,7 +2396,7 @@
           <a:p>
             <a:fld id="{DDCE6D58-9B57-4731-A47B-3CD41B48F0A9}" type="datetimeFigureOut">
               <a:rPr lang="de-CH" smtClean="0"/>
-              <a:t>16.05.2026</a:t>
+              <a:t>17.05.2026</a:t>
             </a:fld>
             <a:endParaRPr lang="de-CH"/>
           </a:p>
@@ -2609,7 +2609,7 @@
           <a:p>
             <a:fld id="{DDCE6D58-9B57-4731-A47B-3CD41B48F0A9}" type="datetimeFigureOut">
               <a:rPr lang="de-CH" smtClean="0"/>
-              <a:t>16.05.2026</a:t>
+              <a:t>17.05.2026</a:t>
             </a:fld>
             <a:endParaRPr lang="de-CH"/>
           </a:p>

</xml_diff>